<commit_message>
fixing axis title in fig 2b
</commit_message>
<xml_diff>
--- a/figures/figure_02.pptx
+++ b/figures/figure_02.pptx
@@ -2,12 +2,12 @@
 <file path=ppt/presentation.xml><?xml version="1.0" encoding="utf-8"?>
 <p:presentation xmlns:a="http://schemas.openxmlformats.org/drawingml/2006/main" xmlns:r="http://schemas.openxmlformats.org/officeDocument/2006/relationships" xmlns:p="http://schemas.openxmlformats.org/presentationml/2006/main" saveSubsetFonts="1">
   <p:sldMasterIdLst>
-    <p:sldMasterId id="2147483660" r:id="rId1"/>
+    <p:sldMasterId id="2147483672" r:id="rId1"/>
   </p:sldMasterIdLst>
   <p:sldIdLst>
     <p:sldId id="256" r:id="rId2"/>
   </p:sldIdLst>
-  <p:sldSz cx="6172200" cy="2743200"/>
+  <p:sldSz cx="6208713" cy="2743200"/>
   <p:notesSz cx="6858000" cy="9144000"/>
   <p:defaultTextStyle>
     <a:defPPr>
@@ -104,7 +104,201 @@
       </a:defRPr>
     </a:lvl9pPr>
   </p:defaultTextStyle>
+  <p:extLst>
+    <p:ext uri="{EFAFB233-063F-42B5-8137-9DF3F51BA10A}">
+      <p15:sldGuideLst xmlns:p15="http://schemas.microsoft.com/office/powerpoint/2012/main"/>
+    </p:ext>
+  </p:extLst>
 </p:presentation>
+</file>
+
+<file path=ppt/revisionInfo.xml><?xml version="1.0" encoding="utf-8"?>
+<p1510:revInfo xmlns:a="http://schemas.openxmlformats.org/drawingml/2006/main" xmlns:r="http://schemas.openxmlformats.org/officeDocument/2006/relationships" xmlns:p1510="http://schemas.microsoft.com/office/powerpoint/2015/10/main">
+  <p1510:revLst>
+    <p1510:client id="{F41769D2-4F2C-47C3-9BA4-73BDE2B094D1}" v="3" dt="2026-09-03T16:44:16.605"/>
+  </p1510:revLst>
+</p1510:revInfo>
+</file>
+
+<file path=ppt/changesInfos/changesInfo1.xml><?xml version="1.0" encoding="utf-8"?>
+<pc:chgInfo xmlns:a="http://schemas.openxmlformats.org/drawingml/2006/main" xmlns:r="http://schemas.openxmlformats.org/officeDocument/2006/relationships" xmlns:ac="http://schemas.microsoft.com/office/drawing/2013/main/command" xmlns:pc="http://schemas.microsoft.com/office/powerpoint/2013/main/command">
+  <pc:docChgLst>
+    <pc:chgData name="Gilbert, Neil" userId="37be9f5c-8f28-415b-96d6-624acf93bb3f" providerId="ADAL" clId="{18ED56B6-1921-416C-9A28-3F6F3C8390B5}"/>
+    <pc:docChg chg="custSel modSld">
+      <pc:chgData name="Gilbert, Neil" userId="37be9f5c-8f28-415b-96d6-624acf93bb3f" providerId="ADAL" clId="{18ED56B6-1921-416C-9A28-3F6F3C8390B5}" dt="2026-09-03T16:48:54.448" v="53" actId="1076"/>
+      <pc:docMkLst>
+        <pc:docMk/>
+      </pc:docMkLst>
+      <pc:sldChg chg="addSp delSp modSp mod">
+        <pc:chgData name="Gilbert, Neil" userId="37be9f5c-8f28-415b-96d6-624acf93bb3f" providerId="ADAL" clId="{18ED56B6-1921-416C-9A28-3F6F3C8390B5}" dt="2026-09-03T16:48:54.448" v="53" actId="1076"/>
+        <pc:sldMkLst>
+          <pc:docMk/>
+          <pc:sldMk cId="470603763" sldId="256"/>
+        </pc:sldMkLst>
+        <pc:spChg chg="mod">
+          <ac:chgData name="Gilbert, Neil" userId="37be9f5c-8f28-415b-96d6-624acf93bb3f" providerId="ADAL" clId="{18ED56B6-1921-416C-9A28-3F6F3C8390B5}" dt="2026-09-03T16:43:56.512" v="47"/>
+          <ac:spMkLst>
+            <pc:docMk/>
+            <pc:sldMk cId="470603763" sldId="256"/>
+            <ac:spMk id="5" creationId="{F2303B2F-7855-2234-5DCE-49175B3E485C}"/>
+          </ac:spMkLst>
+        </pc:spChg>
+        <pc:spChg chg="mod">
+          <ac:chgData name="Gilbert, Neil" userId="37be9f5c-8f28-415b-96d6-624acf93bb3f" providerId="ADAL" clId="{18ED56B6-1921-416C-9A28-3F6F3C8390B5}" dt="2026-09-03T16:43:56.512" v="47"/>
+          <ac:spMkLst>
+            <pc:docMk/>
+            <pc:sldMk cId="470603763" sldId="256"/>
+            <ac:spMk id="6" creationId="{23D28CC5-98A5-7313-8144-8F4C609648A5}"/>
+          </ac:spMkLst>
+        </pc:spChg>
+        <pc:spChg chg="mod">
+          <ac:chgData name="Gilbert, Neil" userId="37be9f5c-8f28-415b-96d6-624acf93bb3f" providerId="ADAL" clId="{18ED56B6-1921-416C-9A28-3F6F3C8390B5}" dt="2026-09-03T16:43:56.512" v="47"/>
+          <ac:spMkLst>
+            <pc:docMk/>
+            <pc:sldMk cId="470603763" sldId="256"/>
+            <ac:spMk id="7" creationId="{7C455A33-8E9F-43F4-ECC8-63F2B41EDAF9}"/>
+          </ac:spMkLst>
+        </pc:spChg>
+        <pc:spChg chg="mod">
+          <ac:chgData name="Gilbert, Neil" userId="37be9f5c-8f28-415b-96d6-624acf93bb3f" providerId="ADAL" clId="{18ED56B6-1921-416C-9A28-3F6F3C8390B5}" dt="2026-09-03T16:43:56.512" v="47"/>
+          <ac:spMkLst>
+            <pc:docMk/>
+            <pc:sldMk cId="470603763" sldId="256"/>
+            <ac:spMk id="8" creationId="{0046218C-8D04-61E7-04F4-ABDCFCC46A32}"/>
+          </ac:spMkLst>
+        </pc:spChg>
+        <pc:spChg chg="mod">
+          <ac:chgData name="Gilbert, Neil" userId="37be9f5c-8f28-415b-96d6-624acf93bb3f" providerId="ADAL" clId="{18ED56B6-1921-416C-9A28-3F6F3C8390B5}" dt="2026-09-03T16:44:16.605" v="49"/>
+          <ac:spMkLst>
+            <pc:docMk/>
+            <pc:sldMk cId="470603763" sldId="256"/>
+            <ac:spMk id="12" creationId="{F2303B2F-7855-2234-5DCE-49175B3E485C}"/>
+          </ac:spMkLst>
+        </pc:spChg>
+        <pc:spChg chg="mod">
+          <ac:chgData name="Gilbert, Neil" userId="37be9f5c-8f28-415b-96d6-624acf93bb3f" providerId="ADAL" clId="{18ED56B6-1921-416C-9A28-3F6F3C8390B5}" dt="2026-09-03T16:43:39.183" v="40" actId="1036"/>
+          <ac:spMkLst>
+            <pc:docMk/>
+            <pc:sldMk cId="470603763" sldId="256"/>
+            <ac:spMk id="16" creationId="{F2303B2F-7855-2234-5DCE-49175B3E485C}"/>
+          </ac:spMkLst>
+        </pc:spChg>
+        <pc:spChg chg="mod">
+          <ac:chgData name="Gilbert, Neil" userId="37be9f5c-8f28-415b-96d6-624acf93bb3f" providerId="ADAL" clId="{18ED56B6-1921-416C-9A28-3F6F3C8390B5}" dt="2026-09-03T16:43:44.782" v="45" actId="1037"/>
+          <ac:spMkLst>
+            <pc:docMk/>
+            <pc:sldMk cId="470603763" sldId="256"/>
+            <ac:spMk id="17" creationId="{23D28CC5-98A5-7313-8144-8F4C609648A5}"/>
+          </ac:spMkLst>
+        </pc:spChg>
+        <pc:spChg chg="mod">
+          <ac:chgData name="Gilbert, Neil" userId="37be9f5c-8f28-415b-96d6-624acf93bb3f" providerId="ADAL" clId="{18ED56B6-1921-416C-9A28-3F6F3C8390B5}" dt="2026-09-03T16:43:14.878" v="4" actId="1038"/>
+          <ac:spMkLst>
+            <pc:docMk/>
+            <pc:sldMk cId="470603763" sldId="256"/>
+            <ac:spMk id="19" creationId="{0046218C-8D04-61E7-04F4-ABDCFCC46A32}"/>
+          </ac:spMkLst>
+        </pc:spChg>
+        <pc:spChg chg="mod">
+          <ac:chgData name="Gilbert, Neil" userId="37be9f5c-8f28-415b-96d6-624acf93bb3f" providerId="ADAL" clId="{18ED56B6-1921-416C-9A28-3F6F3C8390B5}" dt="2026-09-03T16:44:16.605" v="49"/>
+          <ac:spMkLst>
+            <pc:docMk/>
+            <pc:sldMk cId="470603763" sldId="256"/>
+            <ac:spMk id="20" creationId="{23D28CC5-98A5-7313-8144-8F4C609648A5}"/>
+          </ac:spMkLst>
+        </pc:spChg>
+        <pc:spChg chg="mod">
+          <ac:chgData name="Gilbert, Neil" userId="37be9f5c-8f28-415b-96d6-624acf93bb3f" providerId="ADAL" clId="{18ED56B6-1921-416C-9A28-3F6F3C8390B5}" dt="2026-09-03T16:44:16.605" v="49"/>
+          <ac:spMkLst>
+            <pc:docMk/>
+            <pc:sldMk cId="470603763" sldId="256"/>
+            <ac:spMk id="21" creationId="{7C455A33-8E9F-43F4-ECC8-63F2B41EDAF9}"/>
+          </ac:spMkLst>
+        </pc:spChg>
+        <pc:spChg chg="mod">
+          <ac:chgData name="Gilbert, Neil" userId="37be9f5c-8f28-415b-96d6-624acf93bb3f" providerId="ADAL" clId="{18ED56B6-1921-416C-9A28-3F6F3C8390B5}" dt="2026-09-03T16:44:16.605" v="49"/>
+          <ac:spMkLst>
+            <pc:docMk/>
+            <pc:sldMk cId="470603763" sldId="256"/>
+            <ac:spMk id="22" creationId="{0046218C-8D04-61E7-04F4-ABDCFCC46A32}"/>
+          </ac:spMkLst>
+        </pc:spChg>
+        <pc:grpChg chg="add del mod">
+          <ac:chgData name="Gilbert, Neil" userId="37be9f5c-8f28-415b-96d6-624acf93bb3f" providerId="ADAL" clId="{18ED56B6-1921-416C-9A28-3F6F3C8390B5}" dt="2026-09-03T16:44:05.350" v="48" actId="21"/>
+          <ac:grpSpMkLst>
+            <pc:docMk/>
+            <pc:sldMk cId="470603763" sldId="256"/>
+            <ac:grpSpMk id="2" creationId="{7193D5A7-DBCC-74DE-21F4-FFC20B0F4636}"/>
+          </ac:grpSpMkLst>
+        </pc:grpChg>
+        <pc:grpChg chg="add mod">
+          <ac:chgData name="Gilbert, Neil" userId="37be9f5c-8f28-415b-96d6-624acf93bb3f" providerId="ADAL" clId="{18ED56B6-1921-416C-9A28-3F6F3C8390B5}" dt="2026-09-03T16:44:16.605" v="49"/>
+          <ac:grpSpMkLst>
+            <pc:docMk/>
+            <pc:sldMk cId="470603763" sldId="256"/>
+            <ac:grpSpMk id="9" creationId="{7193D5A7-DBCC-74DE-21F4-FFC20B0F4636}"/>
+          </ac:grpSpMkLst>
+        </pc:grpChg>
+        <pc:grpChg chg="del">
+          <ac:chgData name="Gilbert, Neil" userId="37be9f5c-8f28-415b-96d6-624acf93bb3f" providerId="ADAL" clId="{18ED56B6-1921-416C-9A28-3F6F3C8390B5}" dt="2026-09-03T16:43:55.450" v="46" actId="21"/>
+          <ac:grpSpMkLst>
+            <pc:docMk/>
+            <pc:sldMk cId="470603763" sldId="256"/>
+            <ac:grpSpMk id="13" creationId="{7193D5A7-DBCC-74DE-21F4-FFC20B0F4636}"/>
+          </ac:grpSpMkLst>
+        </pc:grpChg>
+        <pc:picChg chg="mod">
+          <ac:chgData name="Gilbert, Neil" userId="37be9f5c-8f28-415b-96d6-624acf93bb3f" providerId="ADAL" clId="{18ED56B6-1921-416C-9A28-3F6F3C8390B5}" dt="2026-09-03T16:43:56.512" v="47"/>
+          <ac:picMkLst>
+            <pc:docMk/>
+            <pc:sldMk cId="470603763" sldId="256"/>
+            <ac:picMk id="3" creationId="{1A3D6F70-6D77-1AE7-42F9-DA3BE6DA71F6}"/>
+          </ac:picMkLst>
+        </pc:picChg>
+        <pc:picChg chg="mod">
+          <ac:chgData name="Gilbert, Neil" userId="37be9f5c-8f28-415b-96d6-624acf93bb3f" providerId="ADAL" clId="{18ED56B6-1921-416C-9A28-3F6F3C8390B5}" dt="2026-09-03T16:43:56.512" v="47"/>
+          <ac:picMkLst>
+            <pc:docMk/>
+            <pc:sldMk cId="470603763" sldId="256"/>
+            <ac:picMk id="4" creationId="{E25FA32C-2262-3484-686E-583ADA0D3F9A}"/>
+          </ac:picMkLst>
+        </pc:picChg>
+        <pc:picChg chg="mod">
+          <ac:chgData name="Gilbert, Neil" userId="37be9f5c-8f28-415b-96d6-624acf93bb3f" providerId="ADAL" clId="{18ED56B6-1921-416C-9A28-3F6F3C8390B5}" dt="2026-09-03T16:44:16.605" v="49"/>
+          <ac:picMkLst>
+            <pc:docMk/>
+            <pc:sldMk cId="470603763" sldId="256"/>
+            <ac:picMk id="10" creationId="{1A3D6F70-6D77-1AE7-42F9-DA3BE6DA71F6}"/>
+          </ac:picMkLst>
+        </pc:picChg>
+        <pc:picChg chg="del mod">
+          <ac:chgData name="Gilbert, Neil" userId="37be9f5c-8f28-415b-96d6-624acf93bb3f" providerId="ADAL" clId="{18ED56B6-1921-416C-9A28-3F6F3C8390B5}" dt="2026-09-03T16:48:39.327" v="50" actId="478"/>
+          <ac:picMkLst>
+            <pc:docMk/>
+            <pc:sldMk cId="470603763" sldId="256"/>
+            <ac:picMk id="11" creationId="{E25FA32C-2262-3484-686E-583ADA0D3F9A}"/>
+          </ac:picMkLst>
+        </pc:picChg>
+        <pc:picChg chg="mod">
+          <ac:chgData name="Gilbert, Neil" userId="37be9f5c-8f28-415b-96d6-624acf93bb3f" providerId="ADAL" clId="{18ED56B6-1921-416C-9A28-3F6F3C8390B5}" dt="2026-09-03T16:43:14.878" v="4" actId="1038"/>
+          <ac:picMkLst>
+            <pc:docMk/>
+            <pc:sldMk cId="470603763" sldId="256"/>
+            <ac:picMk id="15" creationId="{E25FA32C-2262-3484-686E-583ADA0D3F9A}"/>
+          </ac:picMkLst>
+        </pc:picChg>
+        <pc:picChg chg="add mod">
+          <ac:chgData name="Gilbert, Neil" userId="37be9f5c-8f28-415b-96d6-624acf93bb3f" providerId="ADAL" clId="{18ED56B6-1921-416C-9A28-3F6F3C8390B5}" dt="2026-09-03T16:48:54.448" v="53" actId="1076"/>
+          <ac:picMkLst>
+            <pc:docMk/>
+            <pc:sldMk cId="470603763" sldId="256"/>
+            <ac:picMk id="24" creationId="{3D3A23C8-FA56-3CBA-1434-06C2752546E8}"/>
+          </ac:picMkLst>
+        </pc:picChg>
+      </pc:sldChg>
+    </pc:docChg>
+  </pc:docChgLst>
+</pc:chgInfo>
 </file>
 
 <file path=ppt/slideLayouts/slideLayout1.xml><?xml version="1.0" encoding="utf-8"?>
@@ -136,8 +330,8 @@
         </p:nvSpPr>
         <p:spPr>
           <a:xfrm>
-            <a:off x="771525" y="448945"/>
-            <a:ext cx="4629150" cy="955040"/>
+            <a:off x="776089" y="448945"/>
+            <a:ext cx="4656535" cy="955040"/>
           </a:xfrm>
         </p:spPr>
         <p:txBody>
@@ -168,8 +362,8 @@
         </p:nvSpPr>
         <p:spPr>
           <a:xfrm>
-            <a:off x="771525" y="1440815"/>
-            <a:ext cx="4629150" cy="662305"/>
+            <a:off x="776089" y="1440815"/>
+            <a:ext cx="4656535" cy="662305"/>
           </a:xfrm>
         </p:spPr>
         <p:txBody>
@@ -238,7 +432,7 @@
           <a:p>
             <a:fld id="{8903F1AD-52AB-42AD-9792-3F248794A2B0}" type="datetimeFigureOut">
               <a:rPr lang="en-US" smtClean="0"/>
-              <a:t>5/28/2026</a:t>
+              <a:t>9/3/2026</a:t>
             </a:fld>
             <a:endParaRPr lang="en-US"/>
           </a:p>
@@ -289,7 +483,7 @@
     </p:spTree>
     <p:extLst>
       <p:ext uri="{BB962C8B-B14F-4D97-AF65-F5344CB8AC3E}">
-        <p14:creationId xmlns:p14="http://schemas.microsoft.com/office/powerpoint/2010/main" val="3617874175"/>
+        <p14:creationId xmlns:p14="http://schemas.microsoft.com/office/powerpoint/2010/main" val="3446946278"/>
       </p:ext>
     </p:extLst>
   </p:cSld>
@@ -408,7 +602,7 @@
           <a:p>
             <a:fld id="{8903F1AD-52AB-42AD-9792-3F248794A2B0}" type="datetimeFigureOut">
               <a:rPr lang="en-US" smtClean="0"/>
-              <a:t>5/28/2026</a:t>
+              <a:t>9/3/2026</a:t>
             </a:fld>
             <a:endParaRPr lang="en-US"/>
           </a:p>
@@ -459,7 +653,7 @@
     </p:spTree>
     <p:extLst>
       <p:ext uri="{BB962C8B-B14F-4D97-AF65-F5344CB8AC3E}">
-        <p14:creationId xmlns:p14="http://schemas.microsoft.com/office/powerpoint/2010/main" val="1756077211"/>
+        <p14:creationId xmlns:p14="http://schemas.microsoft.com/office/powerpoint/2010/main" val="1236207200"/>
       </p:ext>
     </p:extLst>
   </p:cSld>
@@ -498,8 +692,8 @@
         </p:nvSpPr>
         <p:spPr>
           <a:xfrm>
-            <a:off x="4416980" y="146050"/>
-            <a:ext cx="1330881" cy="2324735"/>
+            <a:off x="4443110" y="146050"/>
+            <a:ext cx="1338754" cy="2324735"/>
           </a:xfrm>
         </p:spPr>
         <p:txBody>
@@ -526,8 +720,8 @@
         </p:nvSpPr>
         <p:spPr>
           <a:xfrm>
-            <a:off x="424339" y="146050"/>
-            <a:ext cx="3915489" cy="2324735"/>
+            <a:off x="426849" y="146050"/>
+            <a:ext cx="3938652" cy="2324735"/>
           </a:xfrm>
         </p:spPr>
         <p:txBody>
@@ -588,7 +782,7 @@
           <a:p>
             <a:fld id="{8903F1AD-52AB-42AD-9792-3F248794A2B0}" type="datetimeFigureOut">
               <a:rPr lang="en-US" smtClean="0"/>
-              <a:t>5/28/2026</a:t>
+              <a:t>9/3/2026</a:t>
             </a:fld>
             <a:endParaRPr lang="en-US"/>
           </a:p>
@@ -639,7 +833,7 @@
     </p:spTree>
     <p:extLst>
       <p:ext uri="{BB962C8B-B14F-4D97-AF65-F5344CB8AC3E}">
-        <p14:creationId xmlns:p14="http://schemas.microsoft.com/office/powerpoint/2010/main" val="3119906677"/>
+        <p14:creationId xmlns:p14="http://schemas.microsoft.com/office/powerpoint/2010/main" val="3541118124"/>
       </p:ext>
     </p:extLst>
   </p:cSld>
@@ -758,7 +952,7 @@
           <a:p>
             <a:fld id="{8903F1AD-52AB-42AD-9792-3F248794A2B0}" type="datetimeFigureOut">
               <a:rPr lang="en-US" smtClean="0"/>
-              <a:t>5/28/2026</a:t>
+              <a:t>9/3/2026</a:t>
             </a:fld>
             <a:endParaRPr lang="en-US"/>
           </a:p>
@@ -809,7 +1003,7 @@
     </p:spTree>
     <p:extLst>
       <p:ext uri="{BB962C8B-B14F-4D97-AF65-F5344CB8AC3E}">
-        <p14:creationId xmlns:p14="http://schemas.microsoft.com/office/powerpoint/2010/main" val="3242266665"/>
+        <p14:creationId xmlns:p14="http://schemas.microsoft.com/office/powerpoint/2010/main" val="2450752411"/>
       </p:ext>
     </p:extLst>
   </p:cSld>
@@ -848,8 +1042,8 @@
         </p:nvSpPr>
         <p:spPr>
           <a:xfrm>
-            <a:off x="421124" y="683895"/>
-            <a:ext cx="5323523" cy="1141095"/>
+            <a:off x="423615" y="683895"/>
+            <a:ext cx="5355015" cy="1141095"/>
           </a:xfrm>
         </p:spPr>
         <p:txBody>
@@ -880,8 +1074,8 @@
         </p:nvSpPr>
         <p:spPr>
           <a:xfrm>
-            <a:off x="421124" y="1835785"/>
-            <a:ext cx="5323523" cy="600075"/>
+            <a:off x="423615" y="1835785"/>
+            <a:ext cx="5355015" cy="600075"/>
           </a:xfrm>
         </p:spPr>
         <p:txBody>
@@ -1004,7 +1198,7 @@
           <a:p>
             <a:fld id="{8903F1AD-52AB-42AD-9792-3F248794A2B0}" type="datetimeFigureOut">
               <a:rPr lang="en-US" smtClean="0"/>
-              <a:t>5/28/2026</a:t>
+              <a:t>9/3/2026</a:t>
             </a:fld>
             <a:endParaRPr lang="en-US"/>
           </a:p>
@@ -1055,7 +1249,7 @@
     </p:spTree>
     <p:extLst>
       <p:ext uri="{BB962C8B-B14F-4D97-AF65-F5344CB8AC3E}">
-        <p14:creationId xmlns:p14="http://schemas.microsoft.com/office/powerpoint/2010/main" val="1326848982"/>
+        <p14:creationId xmlns:p14="http://schemas.microsoft.com/office/powerpoint/2010/main" val="3004574564"/>
       </p:ext>
     </p:extLst>
   </p:cSld>
@@ -1117,8 +1311,8 @@
         </p:nvSpPr>
         <p:spPr>
           <a:xfrm>
-            <a:off x="424339" y="730250"/>
-            <a:ext cx="2623185" cy="1740535"/>
+            <a:off x="426849" y="730250"/>
+            <a:ext cx="2638703" cy="1740535"/>
           </a:xfrm>
         </p:spPr>
         <p:txBody>
@@ -1174,8 +1368,8 @@
         </p:nvSpPr>
         <p:spPr>
           <a:xfrm>
-            <a:off x="3124676" y="730250"/>
-            <a:ext cx="2623185" cy="1740535"/>
+            <a:off x="3143161" y="730250"/>
+            <a:ext cx="2638703" cy="1740535"/>
           </a:xfrm>
         </p:spPr>
         <p:txBody>
@@ -1236,7 +1430,7 @@
           <a:p>
             <a:fld id="{8903F1AD-52AB-42AD-9792-3F248794A2B0}" type="datetimeFigureOut">
               <a:rPr lang="en-US" smtClean="0"/>
-              <a:t>5/28/2026</a:t>
+              <a:t>9/3/2026</a:t>
             </a:fld>
             <a:endParaRPr lang="en-US"/>
           </a:p>
@@ -1287,7 +1481,7 @@
     </p:spTree>
     <p:extLst>
       <p:ext uri="{BB962C8B-B14F-4D97-AF65-F5344CB8AC3E}">
-        <p14:creationId xmlns:p14="http://schemas.microsoft.com/office/powerpoint/2010/main" val="2633527660"/>
+        <p14:creationId xmlns:p14="http://schemas.microsoft.com/office/powerpoint/2010/main" val="96117573"/>
       </p:ext>
     </p:extLst>
   </p:cSld>
@@ -1326,8 +1520,8 @@
         </p:nvSpPr>
         <p:spPr>
           <a:xfrm>
-            <a:off x="425142" y="146050"/>
-            <a:ext cx="5323523" cy="530225"/>
+            <a:off x="427658" y="146050"/>
+            <a:ext cx="5355015" cy="530225"/>
           </a:xfrm>
         </p:spPr>
         <p:txBody>
@@ -1354,8 +1548,8 @@
         </p:nvSpPr>
         <p:spPr>
           <a:xfrm>
-            <a:off x="425143" y="672465"/>
-            <a:ext cx="2611130" cy="329565"/>
+            <a:off x="427658" y="672465"/>
+            <a:ext cx="2626576" cy="329565"/>
           </a:xfrm>
         </p:spPr>
         <p:txBody>
@@ -1419,8 +1613,8 @@
         </p:nvSpPr>
         <p:spPr>
           <a:xfrm>
-            <a:off x="425143" y="1002030"/>
-            <a:ext cx="2611130" cy="1473835"/>
+            <a:off x="427658" y="1002030"/>
+            <a:ext cx="2626576" cy="1473835"/>
           </a:xfrm>
         </p:spPr>
         <p:txBody>
@@ -1476,8 +1670,8 @@
         </p:nvSpPr>
         <p:spPr>
           <a:xfrm>
-            <a:off x="3124676" y="672465"/>
-            <a:ext cx="2623989" cy="329565"/>
+            <a:off x="3143161" y="672465"/>
+            <a:ext cx="2639512" cy="329565"/>
           </a:xfrm>
         </p:spPr>
         <p:txBody>
@@ -1541,8 +1735,8 @@
         </p:nvSpPr>
         <p:spPr>
           <a:xfrm>
-            <a:off x="3124676" y="1002030"/>
-            <a:ext cx="2623989" cy="1473835"/>
+            <a:off x="3143161" y="1002030"/>
+            <a:ext cx="2639512" cy="1473835"/>
           </a:xfrm>
         </p:spPr>
         <p:txBody>
@@ -1603,7 +1797,7 @@
           <a:p>
             <a:fld id="{8903F1AD-52AB-42AD-9792-3F248794A2B0}" type="datetimeFigureOut">
               <a:rPr lang="en-US" smtClean="0"/>
-              <a:t>5/28/2026</a:t>
+              <a:t>9/3/2026</a:t>
             </a:fld>
             <a:endParaRPr lang="en-US"/>
           </a:p>
@@ -1654,7 +1848,7 @@
     </p:spTree>
     <p:extLst>
       <p:ext uri="{BB962C8B-B14F-4D97-AF65-F5344CB8AC3E}">
-        <p14:creationId xmlns:p14="http://schemas.microsoft.com/office/powerpoint/2010/main" val="1294361495"/>
+        <p14:creationId xmlns:p14="http://schemas.microsoft.com/office/powerpoint/2010/main" val="2706158982"/>
       </p:ext>
     </p:extLst>
   </p:cSld>
@@ -1721,7 +1915,7 @@
           <a:p>
             <a:fld id="{8903F1AD-52AB-42AD-9792-3F248794A2B0}" type="datetimeFigureOut">
               <a:rPr lang="en-US" smtClean="0"/>
-              <a:t>5/28/2026</a:t>
+              <a:t>9/3/2026</a:t>
             </a:fld>
             <a:endParaRPr lang="en-US"/>
           </a:p>
@@ -1772,7 +1966,7 @@
     </p:spTree>
     <p:extLst>
       <p:ext uri="{BB962C8B-B14F-4D97-AF65-F5344CB8AC3E}">
-        <p14:creationId xmlns:p14="http://schemas.microsoft.com/office/powerpoint/2010/main" val="1515622294"/>
+        <p14:creationId xmlns:p14="http://schemas.microsoft.com/office/powerpoint/2010/main" val="2620310474"/>
       </p:ext>
     </p:extLst>
   </p:cSld>
@@ -1816,7 +2010,7 @@
           <a:p>
             <a:fld id="{8903F1AD-52AB-42AD-9792-3F248794A2B0}" type="datetimeFigureOut">
               <a:rPr lang="en-US" smtClean="0"/>
-              <a:t>5/28/2026</a:t>
+              <a:t>9/3/2026</a:t>
             </a:fld>
             <a:endParaRPr lang="en-US"/>
           </a:p>
@@ -1867,7 +2061,7 @@
     </p:spTree>
     <p:extLst>
       <p:ext uri="{BB962C8B-B14F-4D97-AF65-F5344CB8AC3E}">
-        <p14:creationId xmlns:p14="http://schemas.microsoft.com/office/powerpoint/2010/main" val="3179300934"/>
+        <p14:creationId xmlns:p14="http://schemas.microsoft.com/office/powerpoint/2010/main" val="1674466415"/>
       </p:ext>
     </p:extLst>
   </p:cSld>
@@ -1906,8 +2100,8 @@
         </p:nvSpPr>
         <p:spPr>
           <a:xfrm>
-            <a:off x="425143" y="182880"/>
-            <a:ext cx="1990695" cy="640080"/>
+            <a:off x="427658" y="182880"/>
+            <a:ext cx="2002471" cy="640080"/>
           </a:xfrm>
         </p:spPr>
         <p:txBody>
@@ -1938,8 +2132,8 @@
         </p:nvSpPr>
         <p:spPr>
           <a:xfrm>
-            <a:off x="2623989" y="394970"/>
-            <a:ext cx="3124676" cy="1949450"/>
+            <a:off x="2639512" y="394970"/>
+            <a:ext cx="3143161" cy="1949450"/>
           </a:xfrm>
         </p:spPr>
         <p:txBody>
@@ -2023,8 +2217,8 @@
         </p:nvSpPr>
         <p:spPr>
           <a:xfrm>
-            <a:off x="425143" y="822960"/>
-            <a:ext cx="1990695" cy="1524635"/>
+            <a:off x="427658" y="822960"/>
+            <a:ext cx="2002471" cy="1524635"/>
           </a:xfrm>
         </p:spPr>
         <p:txBody>
@@ -2093,7 +2287,7 @@
           <a:p>
             <a:fld id="{8903F1AD-52AB-42AD-9792-3F248794A2B0}" type="datetimeFigureOut">
               <a:rPr lang="en-US" smtClean="0"/>
-              <a:t>5/28/2026</a:t>
+              <a:t>9/3/2026</a:t>
             </a:fld>
             <a:endParaRPr lang="en-US"/>
           </a:p>
@@ -2144,7 +2338,7 @@
     </p:spTree>
     <p:extLst>
       <p:ext uri="{BB962C8B-B14F-4D97-AF65-F5344CB8AC3E}">
-        <p14:creationId xmlns:p14="http://schemas.microsoft.com/office/powerpoint/2010/main" val="3836147229"/>
+        <p14:creationId xmlns:p14="http://schemas.microsoft.com/office/powerpoint/2010/main" val="2660144977"/>
       </p:ext>
     </p:extLst>
   </p:cSld>
@@ -2183,8 +2377,8 @@
         </p:nvSpPr>
         <p:spPr>
           <a:xfrm>
-            <a:off x="425143" y="182880"/>
-            <a:ext cx="1990695" cy="640080"/>
+            <a:off x="427658" y="182880"/>
+            <a:ext cx="2002471" cy="640080"/>
           </a:xfrm>
         </p:spPr>
         <p:txBody>
@@ -2215,8 +2409,8 @@
         </p:nvSpPr>
         <p:spPr>
           <a:xfrm>
-            <a:off x="2623989" y="394970"/>
-            <a:ext cx="3124676" cy="1949450"/>
+            <a:off x="2639512" y="394970"/>
+            <a:ext cx="3143161" cy="1949450"/>
           </a:xfrm>
         </p:spPr>
         <p:txBody>
@@ -2280,8 +2474,8 @@
         </p:nvSpPr>
         <p:spPr>
           <a:xfrm>
-            <a:off x="425143" y="822960"/>
-            <a:ext cx="1990695" cy="1524635"/>
+            <a:off x="427658" y="822960"/>
+            <a:ext cx="2002471" cy="1524635"/>
           </a:xfrm>
         </p:spPr>
         <p:txBody>
@@ -2350,7 +2544,7 @@
           <a:p>
             <a:fld id="{8903F1AD-52AB-42AD-9792-3F248794A2B0}" type="datetimeFigureOut">
               <a:rPr lang="en-US" smtClean="0"/>
-              <a:t>5/28/2026</a:t>
+              <a:t>9/3/2026</a:t>
             </a:fld>
             <a:endParaRPr lang="en-US"/>
           </a:p>
@@ -2401,7 +2595,7 @@
     </p:spTree>
     <p:extLst>
       <p:ext uri="{BB962C8B-B14F-4D97-AF65-F5344CB8AC3E}">
-        <p14:creationId xmlns:p14="http://schemas.microsoft.com/office/powerpoint/2010/main" val="2955343793"/>
+        <p14:creationId xmlns:p14="http://schemas.microsoft.com/office/powerpoint/2010/main" val="49231819"/>
       </p:ext>
     </p:extLst>
   </p:cSld>
@@ -2445,8 +2639,8 @@
         </p:nvSpPr>
         <p:spPr>
           <a:xfrm>
-            <a:off x="424339" y="146050"/>
-            <a:ext cx="5323523" cy="530225"/>
+            <a:off x="426849" y="146050"/>
+            <a:ext cx="5355015" cy="530225"/>
           </a:xfrm>
           <a:prstGeom prst="rect">
             <a:avLst/>
@@ -2478,8 +2672,8 @@
         </p:nvSpPr>
         <p:spPr>
           <a:xfrm>
-            <a:off x="424339" y="730250"/>
-            <a:ext cx="5323523" cy="1740535"/>
+            <a:off x="426849" y="730250"/>
+            <a:ext cx="5355015" cy="1740535"/>
           </a:xfrm>
           <a:prstGeom prst="rect">
             <a:avLst/>
@@ -2540,8 +2734,8 @@
         </p:nvSpPr>
         <p:spPr>
           <a:xfrm>
-            <a:off x="424339" y="2542540"/>
-            <a:ext cx="1388745" cy="146050"/>
+            <a:off x="426849" y="2542540"/>
+            <a:ext cx="1396960" cy="146050"/>
           </a:xfrm>
           <a:prstGeom prst="rect">
             <a:avLst/>
@@ -2563,7 +2757,7 @@
           <a:p>
             <a:fld id="{8903F1AD-52AB-42AD-9792-3F248794A2B0}" type="datetimeFigureOut">
               <a:rPr lang="en-US" smtClean="0"/>
-              <a:t>5/28/2026</a:t>
+              <a:t>9/3/2026</a:t>
             </a:fld>
             <a:endParaRPr lang="en-US"/>
           </a:p>
@@ -2581,8 +2775,8 @@
         </p:nvSpPr>
         <p:spPr>
           <a:xfrm>
-            <a:off x="2044541" y="2542540"/>
-            <a:ext cx="2083118" cy="146050"/>
+            <a:off x="2056636" y="2542540"/>
+            <a:ext cx="2095441" cy="146050"/>
           </a:xfrm>
           <a:prstGeom prst="rect">
             <a:avLst/>
@@ -2618,8 +2812,8 @@
         </p:nvSpPr>
         <p:spPr>
           <a:xfrm>
-            <a:off x="4359116" y="2542540"/>
-            <a:ext cx="1388745" cy="146050"/>
+            <a:off x="4384904" y="2542540"/>
+            <a:ext cx="1396960" cy="146050"/>
           </a:xfrm>
           <a:prstGeom prst="rect">
             <a:avLst/>
@@ -2650,23 +2844,23 @@
     </p:spTree>
     <p:extLst>
       <p:ext uri="{BB962C8B-B14F-4D97-AF65-F5344CB8AC3E}">
-        <p14:creationId xmlns:p14="http://schemas.microsoft.com/office/powerpoint/2010/main" val="1018538052"/>
+        <p14:creationId xmlns:p14="http://schemas.microsoft.com/office/powerpoint/2010/main" val="1834496264"/>
       </p:ext>
     </p:extLst>
   </p:cSld>
   <p:clrMap bg1="lt1" tx1="dk1" bg2="lt2" tx2="dk2" accent1="accent1" accent2="accent2" accent3="accent3" accent4="accent4" accent5="accent5" accent6="accent6" hlink="hlink" folHlink="folHlink"/>
   <p:sldLayoutIdLst>
-    <p:sldLayoutId id="2147483661" r:id="rId1"/>
-    <p:sldLayoutId id="2147483662" r:id="rId2"/>
-    <p:sldLayoutId id="2147483663" r:id="rId3"/>
-    <p:sldLayoutId id="2147483664" r:id="rId4"/>
-    <p:sldLayoutId id="2147483665" r:id="rId5"/>
-    <p:sldLayoutId id="2147483666" r:id="rId6"/>
-    <p:sldLayoutId id="2147483667" r:id="rId7"/>
-    <p:sldLayoutId id="2147483668" r:id="rId8"/>
-    <p:sldLayoutId id="2147483669" r:id="rId9"/>
-    <p:sldLayoutId id="2147483670" r:id="rId10"/>
-    <p:sldLayoutId id="2147483671" r:id="rId11"/>
+    <p:sldLayoutId id="2147483673" r:id="rId1"/>
+    <p:sldLayoutId id="2147483674" r:id="rId2"/>
+    <p:sldLayoutId id="2147483675" r:id="rId3"/>
+    <p:sldLayoutId id="2147483676" r:id="rId4"/>
+    <p:sldLayoutId id="2147483677" r:id="rId5"/>
+    <p:sldLayoutId id="2147483678" r:id="rId6"/>
+    <p:sldLayoutId id="2147483679" r:id="rId7"/>
+    <p:sldLayoutId id="2147483680" r:id="rId8"/>
+    <p:sldLayoutId id="2147483681" r:id="rId9"/>
+    <p:sldLayoutId id="2147483682" r:id="rId10"/>
+    <p:sldLayoutId id="2147483683" r:id="rId11"/>
   </p:sldLayoutIdLst>
   <p:txStyles>
     <p:titleStyle>
@@ -2970,7 +3164,7 @@
       </p:grpSpPr>
       <p:grpSp>
         <p:nvGrpSpPr>
-          <p:cNvPr id="13" name="Group 12">
+          <p:cNvPr id="9" name="Group 8">
             <a:extLst>
               <a:ext uri="{FF2B5EF4-FFF2-40B4-BE49-F238E27FC236}">
                 <a16:creationId xmlns:a16="http://schemas.microsoft.com/office/drawing/2014/main" id="{7193D5A7-DBCC-74DE-21F4-FFC20B0F4636}"/>
@@ -2983,14 +3177,14 @@
         <p:grpSpPr>
           <a:xfrm>
             <a:off x="0" y="0"/>
-            <a:ext cx="6176971" cy="2743206"/>
+            <a:ext cx="2551114" cy="2743206"/>
             <a:chOff x="0" y="0"/>
-            <a:chExt cx="6176971" cy="2743206"/>
+            <a:chExt cx="2551114" cy="2743206"/>
           </a:xfrm>
         </p:grpSpPr>
         <p:pic>
           <p:nvPicPr>
-            <p:cNvPr id="14" name="Picture 13">
+            <p:cNvPr id="10" name="Picture 9">
               <a:extLst>
                 <a:ext uri="{FF2B5EF4-FFF2-40B4-BE49-F238E27FC236}">
                   <a16:creationId xmlns:a16="http://schemas.microsoft.com/office/drawing/2014/main" id="{1A3D6F70-6D77-1AE7-42F9-DA3BE6DA71F6}"/>
@@ -3024,45 +3218,9 @@
             </a:prstGeom>
           </p:spPr>
         </p:pic>
-        <p:pic>
-          <p:nvPicPr>
-            <p:cNvPr id="15" name="Picture 14">
-              <a:extLst>
-                <a:ext uri="{FF2B5EF4-FFF2-40B4-BE49-F238E27FC236}">
-                  <a16:creationId xmlns:a16="http://schemas.microsoft.com/office/drawing/2014/main" id="{E25FA32C-2262-3484-686E-583ADA0D3F9A}"/>
-                </a:ext>
-              </a:extLst>
-            </p:cNvPr>
-            <p:cNvPicPr>
-              <a:picLocks noChangeAspect="1"/>
-            </p:cNvPicPr>
-            <p:nvPr/>
-          </p:nvPicPr>
-          <p:blipFill>
-            <a:blip r:embed="rId3">
-              <a:extLst>
-                <a:ext uri="{28A0092B-C50C-407E-A947-70E740481C1C}">
-                  <a14:useLocalDpi xmlns:a14="http://schemas.microsoft.com/office/drawing/2010/main" val="0"/>
-                </a:ext>
-              </a:extLst>
-            </a:blip>
-            <a:stretch>
-              <a:fillRect/>
-            </a:stretch>
-          </p:blipFill>
-          <p:spPr>
-            <a:xfrm>
-              <a:off x="2519364" y="0"/>
-              <a:ext cx="3657607" cy="2743206"/>
-            </a:xfrm>
-            <a:prstGeom prst="rect">
-              <a:avLst/>
-            </a:prstGeom>
-          </p:spPr>
-        </p:pic>
         <p:sp>
           <p:nvSpPr>
-            <p:cNvPr id="16" name="Rectangle 15">
+            <p:cNvPr id="12" name="Rectangle 11">
               <a:extLst>
                 <a:ext uri="{FF2B5EF4-FFF2-40B4-BE49-F238E27FC236}">
                   <a16:creationId xmlns:a16="http://schemas.microsoft.com/office/drawing/2014/main" id="{F2303B2F-7855-2234-5DCE-49175B3E485C}"/>
@@ -3074,7 +3232,7 @@
           </p:nvSpPr>
           <p:spPr>
             <a:xfrm>
-              <a:off x="816294" y="652465"/>
+              <a:off x="721044" y="658815"/>
               <a:ext cx="1517341" cy="495300"/>
             </a:xfrm>
             <a:prstGeom prst="rect">
@@ -3121,7 +3279,7 @@
         </p:sp>
         <p:sp>
           <p:nvSpPr>
-            <p:cNvPr id="17" name="Rectangle 16">
+            <p:cNvPr id="20" name="Rectangle 19">
               <a:extLst>
                 <a:ext uri="{FF2B5EF4-FFF2-40B4-BE49-F238E27FC236}">
                   <a16:creationId xmlns:a16="http://schemas.microsoft.com/office/drawing/2014/main" id="{23D28CC5-98A5-7313-8144-8F4C609648A5}"/>
@@ -3133,7 +3291,7 @@
           </p:nvSpPr>
           <p:spPr>
             <a:xfrm>
-              <a:off x="1143002" y="1062038"/>
+              <a:off x="984252" y="1062038"/>
               <a:ext cx="1517341" cy="495300"/>
             </a:xfrm>
             <a:prstGeom prst="rect">
@@ -3179,7 +3337,7 @@
         </p:sp>
         <p:sp>
           <p:nvSpPr>
-            <p:cNvPr id="18" name="Rectangle 17">
+            <p:cNvPr id="21" name="Rectangle 20">
               <a:extLst>
                 <a:ext uri="{FF2B5EF4-FFF2-40B4-BE49-F238E27FC236}">
                   <a16:creationId xmlns:a16="http://schemas.microsoft.com/office/drawing/2014/main" id="{7C455A33-8E9F-43F4-ECC8-63F2B41EDAF9}"/>
@@ -3238,7 +3396,7 @@
         </p:sp>
         <p:sp>
           <p:nvSpPr>
-            <p:cNvPr id="19" name="Rectangle 18">
+            <p:cNvPr id="22" name="Rectangle 21">
               <a:extLst>
                 <a:ext uri="{FF2B5EF4-FFF2-40B4-BE49-F238E27FC236}">
                   <a16:creationId xmlns:a16="http://schemas.microsoft.com/office/drawing/2014/main" id="{0046218C-8D04-61E7-04F4-ABDCFCC46A32}"/>
@@ -3250,7 +3408,7 @@
           </p:nvSpPr>
           <p:spPr>
             <a:xfrm>
-              <a:off x="2388067" y="57149"/>
+              <a:off x="2419817" y="57149"/>
               <a:ext cx="131297" cy="152639"/>
             </a:xfrm>
             <a:prstGeom prst="rect">
@@ -3296,6 +3454,42 @@
           </p:txBody>
         </p:sp>
       </p:grpSp>
+      <p:pic>
+        <p:nvPicPr>
+          <p:cNvPr id="24" name="Picture 23">
+            <a:extLst>
+              <a:ext uri="{FF2B5EF4-FFF2-40B4-BE49-F238E27FC236}">
+                <a16:creationId xmlns:a16="http://schemas.microsoft.com/office/drawing/2014/main" id="{3D3A23C8-FA56-3CBA-1434-06C2752546E8}"/>
+              </a:ext>
+            </a:extLst>
+          </p:cNvPr>
+          <p:cNvPicPr>
+            <a:picLocks noChangeAspect="1"/>
+          </p:cNvPicPr>
+          <p:nvPr/>
+        </p:nvPicPr>
+        <p:blipFill>
+          <a:blip r:embed="rId3">
+            <a:extLst>
+              <a:ext uri="{28A0092B-C50C-407E-A947-70E740481C1C}">
+                <a14:useLocalDpi xmlns:a14="http://schemas.microsoft.com/office/drawing/2010/main" val="0"/>
+              </a:ext>
+            </a:extLst>
+          </a:blip>
+          <a:stretch>
+            <a:fillRect/>
+          </a:stretch>
+        </p:blipFill>
+        <p:spPr>
+          <a:xfrm>
+            <a:off x="2551176" y="0"/>
+            <a:ext cx="3657599" cy="2743200"/>
+          </a:xfrm>
+          <a:prstGeom prst="rect">
+            <a:avLst/>
+          </a:prstGeom>
+        </p:spPr>
+      </p:pic>
     </p:spTree>
     <p:extLst>
       <p:ext uri="{BB962C8B-B14F-4D97-AF65-F5344CB8AC3E}">

</xml_diff>

<commit_message>
tinkering with colors in figures
</commit_message>
<xml_diff>
--- a/figures/figure_02.pptx
+++ b/figures/figure_02.pptx
@@ -124,13 +124,13 @@
 <pc:chgInfo xmlns:a="http://schemas.openxmlformats.org/drawingml/2006/main" xmlns:r="http://schemas.openxmlformats.org/officeDocument/2006/relationships" xmlns:ac="http://schemas.microsoft.com/office/drawing/2013/main/command" xmlns:pc="http://schemas.microsoft.com/office/powerpoint/2013/main/command">
   <pc:docChgLst>
     <pc:chgData name="Gilbert, Neil" userId="37be9f5c-8f28-415b-96d6-624acf93bb3f" providerId="ADAL" clId="{18ED56B6-1921-416C-9A28-3F6F3C8390B5}"/>
-    <pc:docChg chg="custSel modSld">
-      <pc:chgData name="Gilbert, Neil" userId="37be9f5c-8f28-415b-96d6-624acf93bb3f" providerId="ADAL" clId="{18ED56B6-1921-416C-9A28-3F6F3C8390B5}" dt="2026-09-03T16:48:54.448" v="53" actId="1076"/>
+    <pc:docChg chg="undo custSel modSld">
+      <pc:chgData name="Gilbert, Neil" userId="37be9f5c-8f28-415b-96d6-624acf93bb3f" providerId="ADAL" clId="{18ED56B6-1921-416C-9A28-3F6F3C8390B5}" dt="2026-09-03T17:23:01.901" v="102" actId="167"/>
       <pc:docMkLst>
         <pc:docMk/>
       </pc:docMkLst>
       <pc:sldChg chg="addSp delSp modSp mod">
-        <pc:chgData name="Gilbert, Neil" userId="37be9f5c-8f28-415b-96d6-624acf93bb3f" providerId="ADAL" clId="{18ED56B6-1921-416C-9A28-3F6F3C8390B5}" dt="2026-09-03T16:48:54.448" v="53" actId="1076"/>
+        <pc:chgData name="Gilbert, Neil" userId="37be9f5c-8f28-415b-96d6-624acf93bb3f" providerId="ADAL" clId="{18ED56B6-1921-416C-9A28-3F6F3C8390B5}" dt="2026-09-03T17:23:01.901" v="102" actId="167"/>
         <pc:sldMkLst>
           <pc:docMk/>
           <pc:sldMk cId="470603763" sldId="256"/>
@@ -216,7 +216,7 @@
           </ac:spMkLst>
         </pc:spChg>
         <pc:spChg chg="mod">
-          <ac:chgData name="Gilbert, Neil" userId="37be9f5c-8f28-415b-96d6-624acf93bb3f" providerId="ADAL" clId="{18ED56B6-1921-416C-9A28-3F6F3C8390B5}" dt="2026-09-03T16:44:16.605" v="49"/>
+          <ac:chgData name="Gilbert, Neil" userId="37be9f5c-8f28-415b-96d6-624acf93bb3f" providerId="ADAL" clId="{18ED56B6-1921-416C-9A28-3F6F3C8390B5}" dt="2026-09-03T16:50:35.706" v="87" actId="1037"/>
           <ac:spMkLst>
             <pc:docMk/>
             <pc:sldMk cId="470603763" sldId="256"/>
@@ -247,6 +247,14 @@
             <ac:grpSpMk id="13" creationId="{7193D5A7-DBCC-74DE-21F4-FFC20B0F4636}"/>
           </ac:grpSpMkLst>
         </pc:grpChg>
+        <pc:picChg chg="add del mod ord">
+          <ac:chgData name="Gilbert, Neil" userId="37be9f5c-8f28-415b-96d6-624acf93bb3f" providerId="ADAL" clId="{18ED56B6-1921-416C-9A28-3F6F3C8390B5}" dt="2026-09-03T17:11:01.919" v="93" actId="478"/>
+          <ac:picMkLst>
+            <pc:docMk/>
+            <pc:sldMk cId="470603763" sldId="256"/>
+            <ac:picMk id="3" creationId="{02252136-6456-75C1-2297-0B609F63FA7D}"/>
+          </ac:picMkLst>
+        </pc:picChg>
         <pc:picChg chg="mod">
           <ac:chgData name="Gilbert, Neil" userId="37be9f5c-8f28-415b-96d6-624acf93bb3f" providerId="ADAL" clId="{18ED56B6-1921-416C-9A28-3F6F3C8390B5}" dt="2026-09-03T16:43:56.512" v="47"/>
           <ac:picMkLst>
@@ -261,6 +269,22 @@
             <pc:docMk/>
             <pc:sldMk cId="470603763" sldId="256"/>
             <ac:picMk id="4" creationId="{E25FA32C-2262-3484-686E-583ADA0D3F9A}"/>
+          </ac:picMkLst>
+        </pc:picChg>
+        <pc:picChg chg="add del mod ord">
+          <ac:chgData name="Gilbert, Neil" userId="37be9f5c-8f28-415b-96d6-624acf93bb3f" providerId="ADAL" clId="{18ED56B6-1921-416C-9A28-3F6F3C8390B5}" dt="2026-09-03T17:22:40.917" v="98" actId="478"/>
+          <ac:picMkLst>
+            <pc:docMk/>
+            <pc:sldMk cId="470603763" sldId="256"/>
+            <ac:picMk id="5" creationId="{D372136B-27FF-1CA8-B003-1671CF94057F}"/>
+          </ac:picMkLst>
+        </pc:picChg>
+        <pc:picChg chg="add mod ord">
+          <ac:chgData name="Gilbert, Neil" userId="37be9f5c-8f28-415b-96d6-624acf93bb3f" providerId="ADAL" clId="{18ED56B6-1921-416C-9A28-3F6F3C8390B5}" dt="2026-09-03T17:23:01.901" v="102" actId="167"/>
+          <ac:picMkLst>
+            <pc:docMk/>
+            <pc:sldMk cId="470603763" sldId="256"/>
+            <ac:picMk id="7" creationId="{F04D2091-A806-2637-0954-106CFA39FEB5}"/>
           </ac:picMkLst>
         </pc:picChg>
         <pc:picChg chg="mod">
@@ -287,8 +311,8 @@
             <ac:picMk id="15" creationId="{E25FA32C-2262-3484-686E-583ADA0D3F9A}"/>
           </ac:picMkLst>
         </pc:picChg>
-        <pc:picChg chg="add mod">
-          <ac:chgData name="Gilbert, Neil" userId="37be9f5c-8f28-415b-96d6-624acf93bb3f" providerId="ADAL" clId="{18ED56B6-1921-416C-9A28-3F6F3C8390B5}" dt="2026-09-03T16:48:54.448" v="53" actId="1076"/>
+        <pc:picChg chg="add del mod ord">
+          <ac:chgData name="Gilbert, Neil" userId="37be9f5c-8f28-415b-96d6-624acf93bb3f" providerId="ADAL" clId="{18ED56B6-1921-416C-9A28-3F6F3C8390B5}" dt="2026-09-03T17:10:06.373" v="88" actId="478"/>
           <ac:picMkLst>
             <pc:docMk/>
             <pc:sldMk cId="470603763" sldId="256"/>
@@ -3162,6 +3186,42 @@
           <a:chExt cx="0" cy="0"/>
         </a:xfrm>
       </p:grpSpPr>
+      <p:pic>
+        <p:nvPicPr>
+          <p:cNvPr id="7" name="Picture 6">
+            <a:extLst>
+              <a:ext uri="{FF2B5EF4-FFF2-40B4-BE49-F238E27FC236}">
+                <a16:creationId xmlns:a16="http://schemas.microsoft.com/office/drawing/2014/main" id="{F04D2091-A806-2637-0954-106CFA39FEB5}"/>
+              </a:ext>
+            </a:extLst>
+          </p:cNvPr>
+          <p:cNvPicPr>
+            <a:picLocks noChangeAspect="1"/>
+          </p:cNvPicPr>
+          <p:nvPr/>
+        </p:nvPicPr>
+        <p:blipFill>
+          <a:blip r:embed="rId2">
+            <a:extLst>
+              <a:ext uri="{28A0092B-C50C-407E-A947-70E740481C1C}">
+                <a14:useLocalDpi xmlns:a14="http://schemas.microsoft.com/office/drawing/2010/main" val="0"/>
+              </a:ext>
+            </a:extLst>
+          </a:blip>
+          <a:stretch>
+            <a:fillRect/>
+          </a:stretch>
+        </p:blipFill>
+        <p:spPr>
+          <a:xfrm>
+            <a:off x="2551176" y="0"/>
+            <a:ext cx="3657599" cy="2743200"/>
+          </a:xfrm>
+          <a:prstGeom prst="rect">
+            <a:avLst/>
+          </a:prstGeom>
+        </p:spPr>
+      </p:pic>
       <p:grpSp>
         <p:nvGrpSpPr>
           <p:cNvPr id="9" name="Group 8">
@@ -3177,9 +3237,9 @@
         <p:grpSpPr>
           <a:xfrm>
             <a:off x="0" y="0"/>
-            <a:ext cx="2551114" cy="2743206"/>
+            <a:ext cx="2674684" cy="2743206"/>
             <a:chOff x="0" y="0"/>
-            <a:chExt cx="2551114" cy="2743206"/>
+            <a:chExt cx="2674684" cy="2743206"/>
           </a:xfrm>
         </p:grpSpPr>
         <p:pic>
@@ -3197,7 +3257,7 @@
             <p:nvPr/>
           </p:nvPicPr>
           <p:blipFill>
-            <a:blip r:embed="rId2">
+            <a:blip r:embed="rId3">
               <a:extLst>
                 <a:ext uri="{28A0092B-C50C-407E-A947-70E740481C1C}">
                   <a14:useLocalDpi xmlns:a14="http://schemas.microsoft.com/office/drawing/2010/main" val="0"/>
@@ -3408,7 +3468,7 @@
           </p:nvSpPr>
           <p:spPr>
             <a:xfrm>
-              <a:off x="2419817" y="57149"/>
+              <a:off x="2543387" y="57149"/>
               <a:ext cx="131297" cy="152639"/>
             </a:xfrm>
             <a:prstGeom prst="rect">
@@ -3454,42 +3514,6 @@
           </p:txBody>
         </p:sp>
       </p:grpSp>
-      <p:pic>
-        <p:nvPicPr>
-          <p:cNvPr id="24" name="Picture 23">
-            <a:extLst>
-              <a:ext uri="{FF2B5EF4-FFF2-40B4-BE49-F238E27FC236}">
-                <a16:creationId xmlns:a16="http://schemas.microsoft.com/office/drawing/2014/main" id="{3D3A23C8-FA56-3CBA-1434-06C2752546E8}"/>
-              </a:ext>
-            </a:extLst>
-          </p:cNvPr>
-          <p:cNvPicPr>
-            <a:picLocks noChangeAspect="1"/>
-          </p:cNvPicPr>
-          <p:nvPr/>
-        </p:nvPicPr>
-        <p:blipFill>
-          <a:blip r:embed="rId3">
-            <a:extLst>
-              <a:ext uri="{28A0092B-C50C-407E-A947-70E740481C1C}">
-                <a14:useLocalDpi xmlns:a14="http://schemas.microsoft.com/office/drawing/2010/main" val="0"/>
-              </a:ext>
-            </a:extLst>
-          </a:blip>
-          <a:stretch>
-            <a:fillRect/>
-          </a:stretch>
-        </p:blipFill>
-        <p:spPr>
-          <a:xfrm>
-            <a:off x="2551176" y="0"/>
-            <a:ext cx="3657599" cy="2743200"/>
-          </a:xfrm>
-          <a:prstGeom prst="rect">
-            <a:avLst/>
-          </a:prstGeom>
-        </p:spPr>
-      </p:pic>
     </p:spTree>
     <p:extLst>
       <p:ext uri="{BB962C8B-B14F-4D97-AF65-F5344CB8AC3E}">

</xml_diff>